<commit_message>
Polish TEK-UP reservation workflow
</commit_message>
<xml_diff>
--- a/docs/Campus-Resourcely-Spring-Boot-Defense.pptx
+++ b/docs/Campus-Resourcely-Spring-Boot-Defense.pptx
@@ -2,23 +2,23 @@
 <file path=ppt/presentation.xml><?xml version="1.0" encoding="utf-8"?>
 <p:presentation xmlns:p="http://schemas.openxmlformats.org/presentationml/2006/main">
   <p:sldMasterIdLst>
-    <p:sldMasterId xmlns:r="http://schemas.openxmlformats.org/officeDocument/2006/relationships" id="2147483648" r:id="Rf2b660598c3b4860"/>
+    <p:sldMasterId xmlns:r="http://schemas.openxmlformats.org/officeDocument/2006/relationships" id="2147483648" r:id="R491a520a13ab4d16"/>
   </p:sldMasterIdLst>
   <p:notesMasterIdLst>
-    <p:notesMasterId xmlns:r="http://schemas.openxmlformats.org/officeDocument/2006/relationships" r:id="R0d15fefb1d1b4ffd"/>
+    <p:notesMasterId xmlns:r="http://schemas.openxmlformats.org/officeDocument/2006/relationships" r:id="R51c5a2790301497b"/>
   </p:notesMasterIdLst>
   <p:sldIdLst>
-    <p:sldId xmlns:r="http://schemas.openxmlformats.org/officeDocument/2006/relationships" id="256" r:id="R1edced4aabad42ca"/>
-    <p:sldId xmlns:r="http://schemas.openxmlformats.org/officeDocument/2006/relationships" id="257" r:id="Rd9df84fa524c4f17"/>
-    <p:sldId xmlns:r="http://schemas.openxmlformats.org/officeDocument/2006/relationships" id="258" r:id="Rf783120d488d4fd8"/>
-    <p:sldId xmlns:r="http://schemas.openxmlformats.org/officeDocument/2006/relationships" id="259" r:id="Rde7e573f023541ee"/>
-    <p:sldId xmlns:r="http://schemas.openxmlformats.org/officeDocument/2006/relationships" id="260" r:id="R11fe9f1c71754676"/>
-    <p:sldId xmlns:r="http://schemas.openxmlformats.org/officeDocument/2006/relationships" id="261" r:id="R06622c2ba06d49d9"/>
-    <p:sldId xmlns:r="http://schemas.openxmlformats.org/officeDocument/2006/relationships" id="262" r:id="R3216a038d5e2470f"/>
-    <p:sldId xmlns:r="http://schemas.openxmlformats.org/officeDocument/2006/relationships" id="263" r:id="R840ccb0348af4ee5"/>
-    <p:sldId xmlns:r="http://schemas.openxmlformats.org/officeDocument/2006/relationships" id="264" r:id="Rd0286f9f8dd54630"/>
-    <p:sldId xmlns:r="http://schemas.openxmlformats.org/officeDocument/2006/relationships" id="265" r:id="R8f3b8fe334734824"/>
-    <p:sldId xmlns:r="http://schemas.openxmlformats.org/officeDocument/2006/relationships" id="266" r:id="R02318aa53ee3437f"/>
+    <p:sldId xmlns:r="http://schemas.openxmlformats.org/officeDocument/2006/relationships" id="256" r:id="R2936f91abe8842cc"/>
+    <p:sldId xmlns:r="http://schemas.openxmlformats.org/officeDocument/2006/relationships" id="257" r:id="R3a23eee970b14fd3"/>
+    <p:sldId xmlns:r="http://schemas.openxmlformats.org/officeDocument/2006/relationships" id="258" r:id="Rd862d13d6e3c4432"/>
+    <p:sldId xmlns:r="http://schemas.openxmlformats.org/officeDocument/2006/relationships" id="259" r:id="Reb9ce20217924296"/>
+    <p:sldId xmlns:r="http://schemas.openxmlformats.org/officeDocument/2006/relationships" id="260" r:id="R677592bfadf34839"/>
+    <p:sldId xmlns:r="http://schemas.openxmlformats.org/officeDocument/2006/relationships" id="261" r:id="Re0de708eee35435d"/>
+    <p:sldId xmlns:r="http://schemas.openxmlformats.org/officeDocument/2006/relationships" id="262" r:id="Rd813b209f9504683"/>
+    <p:sldId xmlns:r="http://schemas.openxmlformats.org/officeDocument/2006/relationships" id="263" r:id="R7060d63da9a24d83"/>
+    <p:sldId xmlns:r="http://schemas.openxmlformats.org/officeDocument/2006/relationships" id="264" r:id="R7e391319dfbd44e9"/>
+    <p:sldId xmlns:r="http://schemas.openxmlformats.org/officeDocument/2006/relationships" id="265" r:id="Rb9607756eddf4922"/>
+    <p:sldId xmlns:r="http://schemas.openxmlformats.org/officeDocument/2006/relationships" id="266" r:id="Rc85b2cb74cd84d79"/>
   </p:sldIdLst>
   <p:sldSz cx="18288000" cy="10287000"/>
   <p:notesSz cx="6858000" cy="9144000"/>
@@ -1225,7 +1225,7 @@
   </p:cSld>
   <p:clrMap bg1="lt1" tx1="dk1" bg2="lt2" tx2="dk2" accent1="accent1" accent2="accent2" accent3="accent3" accent4="accent4" accent5="accent5" accent6="accent6" hlink="hlink" folHlink="folHlink"/>
   <p:sldLayoutIdLst>
-    <p:sldLayoutId xmlns:r="http://schemas.openxmlformats.org/officeDocument/2006/relationships" id="2147483649" r:id="R40937654ba874a40"/>
+    <p:sldLayoutId xmlns:r="http://schemas.openxmlformats.org/officeDocument/2006/relationships" id="2147483649" r:id="Rc89e52b869104ce4"/>
   </p:sldLayoutIdLst>
   <p:txStyles>
     <p:titleStyle>
@@ -1531,7 +1531,7 @@
           <p:cNvPr id="1" name="kicker-spring-boot-project-defense">
             <a:extLst xmlns:a="http://schemas.openxmlformats.org/drawingml/2006/main">
               <a:ext uri="{FF2B5EF4-FFF2-40B4-BE49-F238E27FC236}">
-                <a16:creationId xmlns:a16="http://schemas.microsoft.com/office/drawing/2014/main" id="{32D8B0CF-E50C-4472-80D7-E830CD79B86F}"/>
+                <a16:creationId xmlns:a16="http://schemas.microsoft.com/office/drawing/2014/main" id="{384A036D-5908-43B2-B5C6-5910DA5BFCFF}"/>
               </a:ext>
             </a:extLst>
           </p:cNvPr>
@@ -1576,7 +1576,7 @@
           <p:cNvPr id="2" name="cover-title">
             <a:extLst xmlns:a="http://schemas.openxmlformats.org/drawingml/2006/main">
               <a:ext uri="{FF2B5EF4-FFF2-40B4-BE49-F238E27FC236}">
-                <a16:creationId xmlns:a16="http://schemas.microsoft.com/office/drawing/2014/main" id="{8AC0E5C5-AED2-409D-B701-A97B84D966F5}"/>
+                <a16:creationId xmlns:a16="http://schemas.microsoft.com/office/drawing/2014/main" id="{941BADE2-77AD-40AD-BA1B-F768613B16B4}"/>
               </a:ext>
             </a:extLst>
           </p:cNvPr>
@@ -1588,7 +1588,7 @@
         <p:spPr>
           <a:xfrm xmlns:a="http://schemas.openxmlformats.org/drawingml/2006/main">
             <a:off x="914400" y="1047750"/>
-            <a:ext cx="4438650" cy="1333500"/>
+            <a:ext cx="4267200" cy="1333500"/>
           </a:xfrm>
           <a:prstGeom xmlns:a="http://schemas.openxmlformats.org/drawingml/2006/main" prst="rect">
             <a:avLst/>
@@ -1611,7 +1611,7 @@
                   <a:srgbClr val="FFFDFC"/>
                 </a:solidFill>
               </a:rPr>
-              <a:t>Campus Resourcely</a:t>
+              <a:t>TEK-UP Resourcely</a:t>
             </a:r>
           </a:p>
         </p:txBody>
@@ -1621,7 +1621,7 @@
           <p:cNvPr id="3" name="cover-rule">
             <a:extLst xmlns:a="http://schemas.openxmlformats.org/drawingml/2006/main">
               <a:ext uri="{FF2B5EF4-FFF2-40B4-BE49-F238E27FC236}">
-                <a16:creationId xmlns:a16="http://schemas.microsoft.com/office/drawing/2014/main" id="{9E70FA88-F68F-4DAC-879F-E240EEE28198}"/>
+                <a16:creationId xmlns:a16="http://schemas.microsoft.com/office/drawing/2014/main" id="{0C9596BB-3571-4CF2-A7E4-B5569068E58E}"/>
               </a:ext>
             </a:extLst>
           </p:cNvPr>
@@ -1654,7 +1654,7 @@
           <p:cNvPr id="4" name="cover-subtitle">
             <a:extLst xmlns:a="http://schemas.openxmlformats.org/drawingml/2006/main">
               <a:ext uri="{FF2B5EF4-FFF2-40B4-BE49-F238E27FC236}">
-                <a16:creationId xmlns:a16="http://schemas.microsoft.com/office/drawing/2014/main" id="{150B6F4F-DE04-4017-B97E-B19A61C1CB3E}"/>
+                <a16:creationId xmlns:a16="http://schemas.microsoft.com/office/drawing/2014/main" id="{5BF5A328-E61E-41B6-8CF6-CAB2AD0D6137}"/>
               </a:ext>
             </a:extLst>
           </p:cNvPr>
@@ -1666,7 +1666,7 @@
         <p:spPr>
           <a:xfrm xmlns:a="http://schemas.openxmlformats.org/drawingml/2006/main">
             <a:off x="914400" y="2952750"/>
-            <a:ext cx="12115800" cy="685800"/>
+            <a:ext cx="12077700" cy="685800"/>
           </a:xfrm>
           <a:prstGeom xmlns:a="http://schemas.openxmlformats.org/drawingml/2006/main" prst="rect">
             <a:avLst/>
@@ -1689,7 +1689,7 @@
                   <a:srgbClr val="DCE7F2"/>
                 </a:solidFill>
               </a:rPr>
-              <a:t>A campus equipment reservation platform with approval workflow, scheduling, notifications, and layered Spring Boot architecture.</a:t>
+              <a:t>A TEK-UP equipment reservation platform with approval workflow, scheduling, notifications, and layered Spring Boot architecture.</a:t>
             </a:r>
           </a:p>
         </p:txBody>
@@ -1699,7 +1699,7 @@
           <p:cNvPr id="5" name="cover-footer">
             <a:extLst xmlns:a="http://schemas.openxmlformats.org/drawingml/2006/main">
               <a:ext uri="{FF2B5EF4-FFF2-40B4-BE49-F238E27FC236}">
-                <a16:creationId xmlns:a16="http://schemas.microsoft.com/office/drawing/2014/main" id="{D52A0471-BA3B-4D32-8EE6-34E324C9B2C4}"/>
+                <a16:creationId xmlns:a16="http://schemas.microsoft.com/office/drawing/2014/main" id="{A8167CEC-5374-432B-A010-EC2622956F46}"/>
               </a:ext>
             </a:extLst>
           </p:cNvPr>
@@ -1742,7 +1742,7 @@
     </p:spTree>
     <p:extLst>
       <p:ext uri="{BB962C8B-B14F-4D97-AF65-F5344CB8AC3E}">
-        <p14:creationId xmlns:p14="http://schemas.microsoft.com/office/powerpoint/2010/main" val="250839878"/>
+        <p14:creationId xmlns:p14="http://schemas.microsoft.com/office/powerpoint/2010/main" val="2120703002"/>
       </p:ext>
     </p:extLst>
   </p:cSld>
@@ -1773,7 +1773,7 @@
           <p:cNvPr id="1" name="kicker-likely-questions">
             <a:extLst xmlns:a="http://schemas.openxmlformats.org/drawingml/2006/main">
               <a:ext uri="{FF2B5EF4-FFF2-40B4-BE49-F238E27FC236}">
-                <a16:creationId xmlns:a16="http://schemas.microsoft.com/office/drawing/2014/main" id="{CCFAA6B2-F2BD-45B2-A215-05502CC28FC4}"/>
+                <a16:creationId xmlns:a16="http://schemas.microsoft.com/office/drawing/2014/main" id="{53D2D144-BE98-4D8B-92AF-0954F29E003E}"/>
               </a:ext>
             </a:extLst>
           </p:cNvPr>
@@ -1818,7 +1818,7 @@
           <p:cNvPr id="2" name="qa-heading">
             <a:extLst xmlns:a="http://schemas.openxmlformats.org/drawingml/2006/main">
               <a:ext uri="{FF2B5EF4-FFF2-40B4-BE49-F238E27FC236}">
-                <a16:creationId xmlns:a16="http://schemas.microsoft.com/office/drawing/2014/main" id="{44F619E7-49C5-4FF3-9C10-12D8A6A70C45}"/>
+                <a16:creationId xmlns:a16="http://schemas.microsoft.com/office/drawing/2014/main" id="{B7F83D7E-43A9-497C-8F29-7987F9EFD998}"/>
               </a:ext>
             </a:extLst>
           </p:cNvPr>
@@ -1863,7 +1863,7 @@
           <p:cNvPr id="3" name="qa-left">
             <a:extLst xmlns:a="http://schemas.openxmlformats.org/drawingml/2006/main">
               <a:ext uri="{FF2B5EF4-FFF2-40B4-BE49-F238E27FC236}">
-                <a16:creationId xmlns:a16="http://schemas.microsoft.com/office/drawing/2014/main" id="{445EEB9D-2861-400F-94D4-4CB59EF944F2}"/>
+                <a16:creationId xmlns:a16="http://schemas.microsoft.com/office/drawing/2014/main" id="{18A28C8F-5B51-4443-A788-C4F243E7B976}"/>
               </a:ext>
             </a:extLst>
           </p:cNvPr>
@@ -1892,7 +1892,7 @@
           <p:cNvPr id="4" name="qa-left-heading">
             <a:extLst xmlns:a="http://schemas.openxmlformats.org/drawingml/2006/main">
               <a:ext uri="{FF2B5EF4-FFF2-40B4-BE49-F238E27FC236}">
-                <a16:creationId xmlns:a16="http://schemas.microsoft.com/office/drawing/2014/main" id="{7AAD9D92-F1C6-4612-BF72-7417FA77C20C}"/>
+                <a16:creationId xmlns:a16="http://schemas.microsoft.com/office/drawing/2014/main" id="{61826DA3-F8CA-47D5-AC42-C6E3F7C4F3BC}"/>
               </a:ext>
             </a:extLst>
           </p:cNvPr>
@@ -1937,7 +1937,7 @@
           <p:cNvPr id="5" name="qa-left-body">
             <a:extLst xmlns:a="http://schemas.openxmlformats.org/drawingml/2006/main">
               <a:ext uri="{FF2B5EF4-FFF2-40B4-BE49-F238E27FC236}">
-                <a16:creationId xmlns:a16="http://schemas.microsoft.com/office/drawing/2014/main" id="{1806BEDD-15C5-434D-B71F-35F3CD6CB4A4}"/>
+                <a16:creationId xmlns:a16="http://schemas.microsoft.com/office/drawing/2014/main" id="{50564E7A-B881-4E9A-92C1-4BDB435C3A4F}"/>
               </a:ext>
             </a:extLst>
           </p:cNvPr>
@@ -2016,7 +2016,7 @@
           <p:cNvPr id="6" name="qa-right">
             <a:extLst xmlns:a="http://schemas.openxmlformats.org/drawingml/2006/main">
               <a:ext uri="{FF2B5EF4-FFF2-40B4-BE49-F238E27FC236}">
-                <a16:creationId xmlns:a16="http://schemas.microsoft.com/office/drawing/2014/main" id="{DC3686BA-0719-4ED3-806A-794D5E6FB9FD}"/>
+                <a16:creationId xmlns:a16="http://schemas.microsoft.com/office/drawing/2014/main" id="{731325B1-06F3-473E-8CEB-BF379B18C1DC}"/>
               </a:ext>
             </a:extLst>
           </p:cNvPr>
@@ -2045,7 +2045,7 @@
           <p:cNvPr id="7" name="qa-right-heading">
             <a:extLst xmlns:a="http://schemas.openxmlformats.org/drawingml/2006/main">
               <a:ext uri="{FF2B5EF4-FFF2-40B4-BE49-F238E27FC236}">
-                <a16:creationId xmlns:a16="http://schemas.microsoft.com/office/drawing/2014/main" id="{CA23ACC9-D44B-4685-9412-67184461A81A}"/>
+                <a16:creationId xmlns:a16="http://schemas.microsoft.com/office/drawing/2014/main" id="{91D98BA3-2E78-49EB-B62A-18F1FAB35F3F}"/>
               </a:ext>
             </a:extLst>
           </p:cNvPr>
@@ -2090,7 +2090,7 @@
           <p:cNvPr id="8" name="qa-right-body">
             <a:extLst xmlns:a="http://schemas.openxmlformats.org/drawingml/2006/main">
               <a:ext uri="{FF2B5EF4-FFF2-40B4-BE49-F238E27FC236}">
-                <a16:creationId xmlns:a16="http://schemas.microsoft.com/office/drawing/2014/main" id="{B8C0F516-A23A-4647-889E-A051DC526494}"/>
+                <a16:creationId xmlns:a16="http://schemas.microsoft.com/office/drawing/2014/main" id="{0CD46D7D-458D-4611-9BB6-2B96FFE2537A}"/>
               </a:ext>
             </a:extLst>
           </p:cNvPr>
@@ -2125,24 +2125,7 @@
                   <a:srgbClr val="52616E"/>
                 </a:solidFill>
               </a:rPr>
-              <a:t>Admin authentication is still demo-style on the frontend, not Spring Security.</a:t>
-            </a:r>
-          </a:p>
-          <a:p xmlns:a="http://schemas.openxmlformats.org/drawingml/2006/main">
-            <a:pPr>
-              <a:defRPr sz="1575">
-                <a:solidFill>
-                  <a:srgbClr val="52616E"/>
-                </a:solidFill>
-              </a:defRPr>
-            </a:pPr>
-            <a:r>
-              <a:rPr sz="1575">
-                <a:solidFill>
-                  <a:srgbClr val="52616E"/>
-                </a:solidFill>
-              </a:rPr>
-              <a:t>H2 is in-memory for presentation simplicity.</a:t>
+              <a:t>The database is local XAMPP MySQL, so the demo depends on MySQL being started.</a:t>
             </a:r>
           </a:p>
           <a:p xmlns:a="http://schemas.openxmlformats.org/drawingml/2006/main">
@@ -2160,6 +2143,23 @@
                 </a:solidFill>
               </a:rPr>
               <a:t>Passwords are plain for demo scope, not production security.</a:t>
+            </a:r>
+          </a:p>
+          <a:p xmlns:a="http://schemas.openxmlformats.org/drawingml/2006/main">
+            <a:pPr>
+              <a:defRPr sz="1575">
+                <a:solidFill>
+                  <a:srgbClr val="52616E"/>
+                </a:solidFill>
+              </a:defRPr>
+            </a:pPr>
+            <a:r>
+              <a:rPr sz="1575">
+                <a:solidFill>
+                  <a:srgbClr val="52616E"/>
+                </a:solidFill>
+              </a:rPr>
+              <a:t>Authentication uses JWT and role-based access control in the Spring Boot backend.</a:t>
             </a:r>
           </a:p>
           <a:p xmlns:a="http://schemas.openxmlformats.org/drawingml/2006/main">
@@ -2184,7 +2184,7 @@
     </p:spTree>
     <p:extLst>
       <p:ext uri="{BB962C8B-B14F-4D97-AF65-F5344CB8AC3E}">
-        <p14:creationId xmlns:p14="http://schemas.microsoft.com/office/powerpoint/2010/main" val="812828711"/>
+        <p14:creationId xmlns:p14="http://schemas.microsoft.com/office/powerpoint/2010/main" val="1009959873"/>
       </p:ext>
     </p:extLst>
   </p:cSld>
@@ -2215,7 +2215,7 @@
           <p:cNvPr id="1" name="kicker-closing-summary">
             <a:extLst xmlns:a="http://schemas.openxmlformats.org/drawingml/2006/main">
               <a:ext uri="{FF2B5EF4-FFF2-40B4-BE49-F238E27FC236}">
-                <a16:creationId xmlns:a16="http://schemas.microsoft.com/office/drawing/2014/main" id="{EBD0A376-4A02-4A4C-B262-9296667F0666}"/>
+                <a16:creationId xmlns:a16="http://schemas.microsoft.com/office/drawing/2014/main" id="{5AF0DBD3-DAF2-4839-9AA7-4BF31CA4612E}"/>
               </a:ext>
             </a:extLst>
           </p:cNvPr>
@@ -2260,7 +2260,7 @@
           <p:cNvPr id="2" name="closing-title">
             <a:extLst xmlns:a="http://schemas.openxmlformats.org/drawingml/2006/main">
               <a:ext uri="{FF2B5EF4-FFF2-40B4-BE49-F238E27FC236}">
-                <a16:creationId xmlns:a16="http://schemas.microsoft.com/office/drawing/2014/main" id="{4125043B-2D54-4C16-95E2-AA0CBAB0C6BF}"/>
+                <a16:creationId xmlns:a16="http://schemas.microsoft.com/office/drawing/2014/main" id="{4B62019E-F37E-4906-9794-AB33DF22A3B9}"/>
               </a:ext>
             </a:extLst>
           </p:cNvPr>
@@ -2305,7 +2305,7 @@
           <p:cNvPr id="3" name="closing-bullets">
             <a:extLst xmlns:a="http://schemas.openxmlformats.org/drawingml/2006/main">
               <a:ext uri="{FF2B5EF4-FFF2-40B4-BE49-F238E27FC236}">
-                <a16:creationId xmlns:a16="http://schemas.microsoft.com/office/drawing/2014/main" id="{55419CD7-2E62-41C4-B237-B27D9E953A83}"/>
+                <a16:creationId xmlns:a16="http://schemas.microsoft.com/office/drawing/2014/main" id="{451FFF8B-E437-419A-8F3D-1175B7A4E116}"/>
               </a:ext>
             </a:extLst>
           </p:cNvPr>
@@ -2391,7 +2391,7 @@
                   <a:srgbClr val="DCE7F2"/>
                 </a:solidFill>
               </a:rPr>
-              <a:t>• Validation, scheduling, notifications, and stock control.</a:t>
+              <a:t>• Validation, scheduling, notifications, and date-capacity control.</a:t>
             </a:r>
           </a:p>
           <a:p xmlns:a="http://schemas.openxmlformats.org/drawingml/2006/main">
@@ -2416,7 +2416,7 @@
     </p:spTree>
     <p:extLst>
       <p:ext uri="{BB962C8B-B14F-4D97-AF65-F5344CB8AC3E}">
-        <p14:creationId xmlns:p14="http://schemas.microsoft.com/office/powerpoint/2010/main" val="796952856"/>
+        <p14:creationId xmlns:p14="http://schemas.microsoft.com/office/powerpoint/2010/main" val="29811111"/>
       </p:ext>
     </p:extLst>
   </p:cSld>
@@ -2447,7 +2447,7 @@
           <p:cNvPr id="1" name="kicker-project-idea">
             <a:extLst xmlns:a="http://schemas.openxmlformats.org/drawingml/2006/main">
               <a:ext uri="{FF2B5EF4-FFF2-40B4-BE49-F238E27FC236}">
-                <a16:creationId xmlns:a16="http://schemas.microsoft.com/office/drawing/2014/main" id="{DF96B5D5-A1A9-492E-8207-91B99434F88F}"/>
+                <a16:creationId xmlns:a16="http://schemas.microsoft.com/office/drawing/2014/main" id="{E883E9CF-0129-42F2-B5FF-FB72F803DA7B}"/>
               </a:ext>
             </a:extLst>
           </p:cNvPr>
@@ -2492,7 +2492,7 @@
           <p:cNvPr id="2" name="problem-heading">
             <a:extLst xmlns:a="http://schemas.openxmlformats.org/drawingml/2006/main">
               <a:ext uri="{FF2B5EF4-FFF2-40B4-BE49-F238E27FC236}">
-                <a16:creationId xmlns:a16="http://schemas.microsoft.com/office/drawing/2014/main" id="{3834788C-D04D-43CF-B1A2-75F15955851B}"/>
+                <a16:creationId xmlns:a16="http://schemas.microsoft.com/office/drawing/2014/main" id="{3B2CB306-6A4F-4FF3-BB3D-6BEA4F655F05}"/>
               </a:ext>
             </a:extLst>
           </p:cNvPr>
@@ -2537,7 +2537,7 @@
           <p:cNvPr id="3" name="problem-subtitle">
             <a:extLst xmlns:a="http://schemas.openxmlformats.org/drawingml/2006/main">
               <a:ext uri="{FF2B5EF4-FFF2-40B4-BE49-F238E27FC236}">
-                <a16:creationId xmlns:a16="http://schemas.microsoft.com/office/drawing/2014/main" id="{5D1CAC10-1CF0-4449-8E2F-06A3DF3F00D4}"/>
+                <a16:creationId xmlns:a16="http://schemas.microsoft.com/office/drawing/2014/main" id="{9C5F1FC8-8F6A-4E27-85F0-14C3219E4874}"/>
               </a:ext>
             </a:extLst>
           </p:cNvPr>
@@ -2549,7 +2549,7 @@
         <p:spPr>
           <a:xfrm xmlns:a="http://schemas.openxmlformats.org/drawingml/2006/main">
             <a:off x="800100" y="1752600"/>
-            <a:ext cx="11830050" cy="647700"/>
+            <a:ext cx="11601450" cy="647700"/>
           </a:xfrm>
           <a:prstGeom xmlns:a="http://schemas.openxmlformats.org/drawingml/2006/main" prst="rect">
             <a:avLst/>
@@ -2572,7 +2572,7 @@
                   <a:srgbClr val="52616E"/>
                 </a:solidFill>
               </a:rPr>
-              <a:t>Universities share expensive resources, but manual borrowing creates stock confusion, late returns, and weak traceability.</a:t>
+              <a:t>Universities share expensive resources, but manual borrowing creates date conflicts, late returns, and weak traceability.</a:t>
             </a:r>
           </a:p>
         </p:txBody>
@@ -2582,7 +2582,7 @@
           <p:cNvPr id="4" name="problem-card">
             <a:extLst xmlns:a="http://schemas.openxmlformats.org/drawingml/2006/main">
               <a:ext uri="{FF2B5EF4-FFF2-40B4-BE49-F238E27FC236}">
-                <a16:creationId xmlns:a16="http://schemas.microsoft.com/office/drawing/2014/main" id="{6A34125A-BC8B-430E-951F-D70B25C1A793}"/>
+                <a16:creationId xmlns:a16="http://schemas.microsoft.com/office/drawing/2014/main" id="{9668D354-5369-4B10-BCF7-61F72610CBA2}"/>
               </a:ext>
             </a:extLst>
           </p:cNvPr>
@@ -2611,7 +2611,7 @@
           <p:cNvPr id="5" name="problem-card-heading">
             <a:extLst xmlns:a="http://schemas.openxmlformats.org/drawingml/2006/main">
               <a:ext uri="{FF2B5EF4-FFF2-40B4-BE49-F238E27FC236}">
-                <a16:creationId xmlns:a16="http://schemas.microsoft.com/office/drawing/2014/main" id="{80F9C768-51CD-4080-B0ED-7B4395E14C10}"/>
+                <a16:creationId xmlns:a16="http://schemas.microsoft.com/office/drawing/2014/main" id="{9EE76238-C3A1-45CD-AEC3-73D034B5AE3B}"/>
               </a:ext>
             </a:extLst>
           </p:cNvPr>
@@ -2656,7 +2656,7 @@
           <p:cNvPr id="6" name="problem-card-body">
             <a:extLst xmlns:a="http://schemas.openxmlformats.org/drawingml/2006/main">
               <a:ext uri="{FF2B5EF4-FFF2-40B4-BE49-F238E27FC236}">
-                <a16:creationId xmlns:a16="http://schemas.microsoft.com/office/drawing/2014/main" id="{BF9C4356-7844-4304-AEA0-311C12A1D6E2}"/>
+                <a16:creationId xmlns:a16="http://schemas.microsoft.com/office/drawing/2014/main" id="{759B97A9-84F5-4C47-BADB-27DBF53DB3A2}"/>
               </a:ext>
             </a:extLst>
           </p:cNvPr>
@@ -2725,7 +2725,7 @@
                   <a:srgbClr val="52616E"/>
                 </a:solidFill>
               </a:rPr>
-              <a:t>The backend tracks stock, due dates, returns, and overdue cases.</a:t>
+              <a:t>The backend tracks date capacity, due dates, returns, and overdue cases.</a:t>
             </a:r>
           </a:p>
         </p:txBody>
@@ -2735,7 +2735,7 @@
           <p:cNvPr id="7" name="value-card">
             <a:extLst xmlns:a="http://schemas.openxmlformats.org/drawingml/2006/main">
               <a:ext uri="{FF2B5EF4-FFF2-40B4-BE49-F238E27FC236}">
-                <a16:creationId xmlns:a16="http://schemas.microsoft.com/office/drawing/2014/main" id="{D36A8255-C6E5-4AEF-BA85-0B1FFB72BA43}"/>
+                <a16:creationId xmlns:a16="http://schemas.microsoft.com/office/drawing/2014/main" id="{8CBBD9C3-9DD4-4409-B468-DA2E2CF8E247}"/>
               </a:ext>
             </a:extLst>
           </p:cNvPr>
@@ -2764,7 +2764,7 @@
           <p:cNvPr id="8" name="value-card-heading">
             <a:extLst xmlns:a="http://schemas.openxmlformats.org/drawingml/2006/main">
               <a:ext uri="{FF2B5EF4-FFF2-40B4-BE49-F238E27FC236}">
-                <a16:creationId xmlns:a16="http://schemas.microsoft.com/office/drawing/2014/main" id="{BDAF465A-C8F3-43E4-9081-E438A454E6BE}"/>
+                <a16:creationId xmlns:a16="http://schemas.microsoft.com/office/drawing/2014/main" id="{EA622D6D-0FA5-43CA-83CE-9B73E28168E7}"/>
               </a:ext>
             </a:extLst>
           </p:cNvPr>
@@ -2809,7 +2809,7 @@
           <p:cNvPr id="9" name="value-card-body">
             <a:extLst xmlns:a="http://schemas.openxmlformats.org/drawingml/2006/main">
               <a:ext uri="{FF2B5EF4-FFF2-40B4-BE49-F238E27FC236}">
-                <a16:creationId xmlns:a16="http://schemas.microsoft.com/office/drawing/2014/main" id="{F393B27D-1C8D-41F6-B4A8-2C9E4183A49B}"/>
+                <a16:creationId xmlns:a16="http://schemas.microsoft.com/office/drawing/2014/main" id="{43023024-E35B-48CA-808B-E08E5CF1C26B}"/>
               </a:ext>
             </a:extLst>
           </p:cNvPr>
@@ -2878,7 +2878,7 @@
                   <a:srgbClr val="52616E"/>
                 </a:solidFill>
               </a:rPr>
-              <a:t>Scheduled notifications before and after deadlines.</a:t>
+              <a:t>Notifications for requests, approvals, rejections, and deadlines.</a:t>
             </a:r>
           </a:p>
           <a:p xmlns:a="http://schemas.openxmlformats.org/drawingml/2006/main">
@@ -2903,7 +2903,7 @@
     </p:spTree>
     <p:extLst>
       <p:ext uri="{BB962C8B-B14F-4D97-AF65-F5344CB8AC3E}">
-        <p14:creationId xmlns:p14="http://schemas.microsoft.com/office/powerpoint/2010/main" val="1733642497"/>
+        <p14:creationId xmlns:p14="http://schemas.microsoft.com/office/powerpoint/2010/main" val="230862306"/>
       </p:ext>
     </p:extLst>
   </p:cSld>
@@ -2934,7 +2934,7 @@
           <p:cNvPr id="1" name="kicker-system-architecture">
             <a:extLst xmlns:a="http://schemas.openxmlformats.org/drawingml/2006/main">
               <a:ext uri="{FF2B5EF4-FFF2-40B4-BE49-F238E27FC236}">
-                <a16:creationId xmlns:a16="http://schemas.microsoft.com/office/drawing/2014/main" id="{C0322C7E-B896-459D-8C6A-DCA641BB1EB6}"/>
+                <a16:creationId xmlns:a16="http://schemas.microsoft.com/office/drawing/2014/main" id="{AE45910D-BA2E-46CC-9BE7-C5B0EEDF2B8D}"/>
               </a:ext>
             </a:extLst>
           </p:cNvPr>
@@ -2979,7 +2979,7 @@
           <p:cNvPr id="2" name="architecture-title">
             <a:extLst xmlns:a="http://schemas.openxmlformats.org/drawingml/2006/main">
               <a:ext uri="{FF2B5EF4-FFF2-40B4-BE49-F238E27FC236}">
-                <a16:creationId xmlns:a16="http://schemas.microsoft.com/office/drawing/2014/main" id="{784CCD0D-1DEB-4B11-8023-E36AD4DFF782}"/>
+                <a16:creationId xmlns:a16="http://schemas.microsoft.com/office/drawing/2014/main" id="{C844DEE7-470C-4885-9FFB-339927A0D43B}"/>
               </a:ext>
             </a:extLst>
           </p:cNvPr>
@@ -3024,7 +3024,7 @@
           <p:cNvPr id="3" name="arch-frontend">
             <a:extLst xmlns:a="http://schemas.openxmlformats.org/drawingml/2006/main">
               <a:ext uri="{FF2B5EF4-FFF2-40B4-BE49-F238E27FC236}">
-                <a16:creationId xmlns:a16="http://schemas.microsoft.com/office/drawing/2014/main" id="{02DFEDBB-9EBC-4566-9772-6E4C46365A10}"/>
+                <a16:creationId xmlns:a16="http://schemas.microsoft.com/office/drawing/2014/main" id="{79AF6AE1-E862-4CC8-82FA-333CF71B13C3}"/>
               </a:ext>
             </a:extLst>
           </p:cNvPr>
@@ -3053,7 +3053,7 @@
           <p:cNvPr id="4" name="arch-frontend-heading">
             <a:extLst xmlns:a="http://schemas.openxmlformats.org/drawingml/2006/main">
               <a:ext uri="{FF2B5EF4-FFF2-40B4-BE49-F238E27FC236}">
-                <a16:creationId xmlns:a16="http://schemas.microsoft.com/office/drawing/2014/main" id="{7BE49CAE-5999-4912-97BB-1D7F37571543}"/>
+                <a16:creationId xmlns:a16="http://schemas.microsoft.com/office/drawing/2014/main" id="{375B3496-12DA-4496-9DF4-B5DBCBCABE39}"/>
               </a:ext>
             </a:extLst>
           </p:cNvPr>
@@ -3098,7 +3098,7 @@
           <p:cNvPr id="5" name="arch-frontend-body">
             <a:extLst xmlns:a="http://schemas.openxmlformats.org/drawingml/2006/main">
               <a:ext uri="{FF2B5EF4-FFF2-40B4-BE49-F238E27FC236}">
-                <a16:creationId xmlns:a16="http://schemas.microsoft.com/office/drawing/2014/main" id="{CFF79336-198A-4B51-BBDB-0F03E60C71AD}"/>
+                <a16:creationId xmlns:a16="http://schemas.microsoft.com/office/drawing/2014/main" id="{4BF75842-9AFD-4969-9DFA-74688715A275}"/>
               </a:ext>
             </a:extLst>
           </p:cNvPr>
@@ -3177,7 +3177,7 @@
           <p:cNvPr id="6" name="arch-backend">
             <a:extLst xmlns:a="http://schemas.openxmlformats.org/drawingml/2006/main">
               <a:ext uri="{FF2B5EF4-FFF2-40B4-BE49-F238E27FC236}">
-                <a16:creationId xmlns:a16="http://schemas.microsoft.com/office/drawing/2014/main" id="{0C28F5CF-CD87-4E7F-A696-AE8E6610647C}"/>
+                <a16:creationId xmlns:a16="http://schemas.microsoft.com/office/drawing/2014/main" id="{6251A94D-D782-4D6D-8E48-E13E08C29036}"/>
               </a:ext>
             </a:extLst>
           </p:cNvPr>
@@ -3206,7 +3206,7 @@
           <p:cNvPr id="7" name="arch-backend-heading">
             <a:extLst xmlns:a="http://schemas.openxmlformats.org/drawingml/2006/main">
               <a:ext uri="{FF2B5EF4-FFF2-40B4-BE49-F238E27FC236}">
-                <a16:creationId xmlns:a16="http://schemas.microsoft.com/office/drawing/2014/main" id="{BEB405B7-9D7F-4D7B-821C-2DD2B601F51D}"/>
+                <a16:creationId xmlns:a16="http://schemas.microsoft.com/office/drawing/2014/main" id="{05BDF08A-BFE6-41C5-AD3C-D8AAB6551B33}"/>
               </a:ext>
             </a:extLst>
           </p:cNvPr>
@@ -3251,7 +3251,7 @@
           <p:cNvPr id="8" name="arch-backend-body">
             <a:extLst xmlns:a="http://schemas.openxmlformats.org/drawingml/2006/main">
               <a:ext uri="{FF2B5EF4-FFF2-40B4-BE49-F238E27FC236}">
-                <a16:creationId xmlns:a16="http://schemas.microsoft.com/office/drawing/2014/main" id="{27CD1B15-3213-4723-9668-98280D64D44F}"/>
+                <a16:creationId xmlns:a16="http://schemas.microsoft.com/office/drawing/2014/main" id="{0DA7456D-53F5-4408-A83D-C1687ECA57AD}"/>
               </a:ext>
             </a:extLst>
           </p:cNvPr>
@@ -3320,7 +3320,7 @@
                   <a:srgbClr val="52616E"/>
                 </a:solidFill>
               </a:rPr>
-              <a:t>Repositories use JPA and H2</a:t>
+              <a:t>Repositories use JPA and MySQL</a:t>
             </a:r>
           </a:p>
         </p:txBody>
@@ -3330,7 +3330,7 @@
           <p:cNvPr id="9" name="arch-db">
             <a:extLst xmlns:a="http://schemas.openxmlformats.org/drawingml/2006/main">
               <a:ext uri="{FF2B5EF4-FFF2-40B4-BE49-F238E27FC236}">
-                <a16:creationId xmlns:a16="http://schemas.microsoft.com/office/drawing/2014/main" id="{92EC7892-A7A5-4B15-B5CA-55CE2EC0D045}"/>
+                <a16:creationId xmlns:a16="http://schemas.microsoft.com/office/drawing/2014/main" id="{8FA559C3-5332-47E9-877E-4CDB08BDF467}"/>
               </a:ext>
             </a:extLst>
           </p:cNvPr>
@@ -3359,7 +3359,7 @@
           <p:cNvPr id="10" name="arch-db-heading">
             <a:extLst xmlns:a="http://schemas.openxmlformats.org/drawingml/2006/main">
               <a:ext uri="{FF2B5EF4-FFF2-40B4-BE49-F238E27FC236}">
-                <a16:creationId xmlns:a16="http://schemas.microsoft.com/office/drawing/2014/main" id="{40167DE2-B2F9-4701-A979-D6B85C0408C8}"/>
+                <a16:creationId xmlns:a16="http://schemas.microsoft.com/office/drawing/2014/main" id="{649D40BD-37D7-4A21-B9B0-537F04EDF3A7}"/>
               </a:ext>
             </a:extLst>
           </p:cNvPr>
@@ -3404,7 +3404,7 @@
           <p:cNvPr id="11" name="arch-db-body">
             <a:extLst xmlns:a="http://schemas.openxmlformats.org/drawingml/2006/main">
               <a:ext uri="{FF2B5EF4-FFF2-40B4-BE49-F238E27FC236}">
-                <a16:creationId xmlns:a16="http://schemas.microsoft.com/office/drawing/2014/main" id="{3F7242D0-6DD1-45CE-98EE-E964510676FA}"/>
+                <a16:creationId xmlns:a16="http://schemas.microsoft.com/office/drawing/2014/main" id="{CBDEF5DB-16A5-4D9F-ADA2-55A00161FEEB}"/>
               </a:ext>
             </a:extLst>
           </p:cNvPr>
@@ -3439,7 +3439,7 @@
                   <a:srgbClr val="52616E"/>
                 </a:solidFill>
               </a:rPr>
-              <a:t>H2 in-memory database</a:t>
+              <a:t>XAMPP MySQL database</a:t>
             </a:r>
           </a:p>
           <a:p xmlns:a="http://schemas.openxmlformats.org/drawingml/2006/main">
@@ -3483,7 +3483,7 @@
           <p:cNvPr id="12" name="arch-rule">
             <a:extLst xmlns:a="http://schemas.openxmlformats.org/drawingml/2006/main">
               <a:ext uri="{FF2B5EF4-FFF2-40B4-BE49-F238E27FC236}">
-                <a16:creationId xmlns:a16="http://schemas.microsoft.com/office/drawing/2014/main" id="{50889C3D-F990-4987-9C8D-2B92D3321FF5}"/>
+                <a16:creationId xmlns:a16="http://schemas.microsoft.com/office/drawing/2014/main" id="{6D9DAD0D-C051-408C-AA17-D0A3CDE0D4B9}"/>
               </a:ext>
             </a:extLst>
           </p:cNvPr>
@@ -3516,7 +3516,7 @@
           <p:cNvPr id="13" name="architecture-bullets">
             <a:extLst xmlns:a="http://schemas.openxmlformats.org/drawingml/2006/main">
               <a:ext uri="{FF2B5EF4-FFF2-40B4-BE49-F238E27FC236}">
-                <a16:creationId xmlns:a16="http://schemas.microsoft.com/office/drawing/2014/main" id="{887900FC-0D3E-49B4-B407-B2B43B2017FD}"/>
+                <a16:creationId xmlns:a16="http://schemas.microsoft.com/office/drawing/2014/main" id="{5799520B-4667-478C-910F-D6CB92AFDA7F}"/>
               </a:ext>
             </a:extLst>
           </p:cNvPr>
@@ -3593,7 +3593,7 @@
     </p:spTree>
     <p:extLst>
       <p:ext uri="{BB962C8B-B14F-4D97-AF65-F5344CB8AC3E}">
-        <p14:creationId xmlns:p14="http://schemas.microsoft.com/office/powerpoint/2010/main" val="1013209259"/>
+        <p14:creationId xmlns:p14="http://schemas.microsoft.com/office/powerpoint/2010/main" val="558020261"/>
       </p:ext>
     </p:extLst>
   </p:cSld>
@@ -3624,7 +3624,7 @@
           <p:cNvPr id="1" name="kicker-spring-boot-structure">
             <a:extLst xmlns:a="http://schemas.openxmlformats.org/drawingml/2006/main">
               <a:ext uri="{FF2B5EF4-FFF2-40B4-BE49-F238E27FC236}">
-                <a16:creationId xmlns:a16="http://schemas.microsoft.com/office/drawing/2014/main" id="{7CEE982D-3DCE-488A-9056-E12C835C2B40}"/>
+                <a16:creationId xmlns:a16="http://schemas.microsoft.com/office/drawing/2014/main" id="{F08098CF-30A6-47A8-9FB2-D31D33991933}"/>
               </a:ext>
             </a:extLst>
           </p:cNvPr>
@@ -3669,7 +3669,7 @@
           <p:cNvPr id="2" name="package-title">
             <a:extLst xmlns:a="http://schemas.openxmlformats.org/drawingml/2006/main">
               <a:ext uri="{FF2B5EF4-FFF2-40B4-BE49-F238E27FC236}">
-                <a16:creationId xmlns:a16="http://schemas.microsoft.com/office/drawing/2014/main" id="{CE5E8BC6-5647-4A3A-B477-FD67495002AC}"/>
+                <a16:creationId xmlns:a16="http://schemas.microsoft.com/office/drawing/2014/main" id="{3FA705D9-2251-4A1D-A16E-6671B541672F}"/>
               </a:ext>
             </a:extLst>
           </p:cNvPr>
@@ -3714,7 +3714,7 @@
           <p:cNvPr id="3" name="package-1">
             <a:extLst xmlns:a="http://schemas.openxmlformats.org/drawingml/2006/main">
               <a:ext uri="{FF2B5EF4-FFF2-40B4-BE49-F238E27FC236}">
-                <a16:creationId xmlns:a16="http://schemas.microsoft.com/office/drawing/2014/main" id="{2F623A7F-C54D-4DDF-8855-FA507C4B4190}"/>
+                <a16:creationId xmlns:a16="http://schemas.microsoft.com/office/drawing/2014/main" id="{EFCB34D8-62E7-404D-B65F-EEFFD51A8095}"/>
               </a:ext>
             </a:extLst>
           </p:cNvPr>
@@ -3743,7 +3743,7 @@
           <p:cNvPr id="4" name="package-1-heading">
             <a:extLst xmlns:a="http://schemas.openxmlformats.org/drawingml/2006/main">
               <a:ext uri="{FF2B5EF4-FFF2-40B4-BE49-F238E27FC236}">
-                <a16:creationId xmlns:a16="http://schemas.microsoft.com/office/drawing/2014/main" id="{8DFB2451-46C3-4708-B8AC-AB05EB3BCA17}"/>
+                <a16:creationId xmlns:a16="http://schemas.microsoft.com/office/drawing/2014/main" id="{AE5581A3-1167-4847-8035-258E690C98DD}"/>
               </a:ext>
             </a:extLst>
           </p:cNvPr>
@@ -3788,7 +3788,7 @@
           <p:cNvPr id="5" name="package-1-body">
             <a:extLst xmlns:a="http://schemas.openxmlformats.org/drawingml/2006/main">
               <a:ext uri="{FF2B5EF4-FFF2-40B4-BE49-F238E27FC236}">
-                <a16:creationId xmlns:a16="http://schemas.microsoft.com/office/drawing/2014/main" id="{DC6E8C9D-EB07-43B3-8287-C376F1370883}"/>
+                <a16:creationId xmlns:a16="http://schemas.microsoft.com/office/drawing/2014/main" id="{3618445F-4039-4F1F-B736-0DE968DB1408}"/>
               </a:ext>
             </a:extLst>
           </p:cNvPr>
@@ -3901,7 +3901,7 @@
           <p:cNvPr id="6" name="package-2">
             <a:extLst xmlns:a="http://schemas.openxmlformats.org/drawingml/2006/main">
               <a:ext uri="{FF2B5EF4-FFF2-40B4-BE49-F238E27FC236}">
-                <a16:creationId xmlns:a16="http://schemas.microsoft.com/office/drawing/2014/main" id="{7D6E611D-DCBE-44DB-97BC-DA2C9F3B8561}"/>
+                <a16:creationId xmlns:a16="http://schemas.microsoft.com/office/drawing/2014/main" id="{331D3AAF-9911-44A2-83B8-8E6FCE569E30}"/>
               </a:ext>
             </a:extLst>
           </p:cNvPr>
@@ -3930,7 +3930,7 @@
           <p:cNvPr id="7" name="package-2-heading">
             <a:extLst xmlns:a="http://schemas.openxmlformats.org/drawingml/2006/main">
               <a:ext uri="{FF2B5EF4-FFF2-40B4-BE49-F238E27FC236}">
-                <a16:creationId xmlns:a16="http://schemas.microsoft.com/office/drawing/2014/main" id="{6056F404-CFC6-4C45-9880-5DC975019C6C}"/>
+                <a16:creationId xmlns:a16="http://schemas.microsoft.com/office/drawing/2014/main" id="{041F0347-E0CF-490F-99A6-C4D73CEEB47C}"/>
               </a:ext>
             </a:extLst>
           </p:cNvPr>
@@ -3975,7 +3975,7 @@
           <p:cNvPr id="8" name="package-2-body">
             <a:extLst xmlns:a="http://schemas.openxmlformats.org/drawingml/2006/main">
               <a:ext uri="{FF2B5EF4-FFF2-40B4-BE49-F238E27FC236}">
-                <a16:creationId xmlns:a16="http://schemas.microsoft.com/office/drawing/2014/main" id="{F37E722D-893D-4F70-B4C9-DFE79735BDA0}"/>
+                <a16:creationId xmlns:a16="http://schemas.microsoft.com/office/drawing/2014/main" id="{0EB3B61A-9124-48FF-8873-BBD4331E4F97}"/>
               </a:ext>
             </a:extLst>
           </p:cNvPr>
@@ -4088,7 +4088,7 @@
           <p:cNvPr id="9" name="package-3">
             <a:extLst xmlns:a="http://schemas.openxmlformats.org/drawingml/2006/main">
               <a:ext uri="{FF2B5EF4-FFF2-40B4-BE49-F238E27FC236}">
-                <a16:creationId xmlns:a16="http://schemas.microsoft.com/office/drawing/2014/main" id="{99D31813-2A49-4531-A72C-8C0ADD03E228}"/>
+                <a16:creationId xmlns:a16="http://schemas.microsoft.com/office/drawing/2014/main" id="{707AD3BE-13DF-4B74-93D6-A9151B51D590}"/>
               </a:ext>
             </a:extLst>
           </p:cNvPr>
@@ -4117,7 +4117,7 @@
           <p:cNvPr id="10" name="package-3-heading">
             <a:extLst xmlns:a="http://schemas.openxmlformats.org/drawingml/2006/main">
               <a:ext uri="{FF2B5EF4-FFF2-40B4-BE49-F238E27FC236}">
-                <a16:creationId xmlns:a16="http://schemas.microsoft.com/office/drawing/2014/main" id="{42AFAE51-0EAB-43AB-B45A-7CF37C42A6ED}"/>
+                <a16:creationId xmlns:a16="http://schemas.microsoft.com/office/drawing/2014/main" id="{6BA61102-1FBB-4630-AEA2-E56304FA2CD6}"/>
               </a:ext>
             </a:extLst>
           </p:cNvPr>
@@ -4162,7 +4162,7 @@
           <p:cNvPr id="11" name="package-3-body">
             <a:extLst xmlns:a="http://schemas.openxmlformats.org/drawingml/2006/main">
               <a:ext uri="{FF2B5EF4-FFF2-40B4-BE49-F238E27FC236}">
-                <a16:creationId xmlns:a16="http://schemas.microsoft.com/office/drawing/2014/main" id="{17D1961B-859B-4325-93ED-E0A8A02D6617}"/>
+                <a16:creationId xmlns:a16="http://schemas.microsoft.com/office/drawing/2014/main" id="{24865386-734F-4AAF-8115-B6C50CBACE77}"/>
               </a:ext>
             </a:extLst>
           </p:cNvPr>
@@ -4273,7 +4273,7 @@
     </p:spTree>
     <p:extLst>
       <p:ext uri="{BB962C8B-B14F-4D97-AF65-F5344CB8AC3E}">
-        <p14:creationId xmlns:p14="http://schemas.microsoft.com/office/powerpoint/2010/main" val="547251959"/>
+        <p14:creationId xmlns:p14="http://schemas.microsoft.com/office/powerpoint/2010/main" val="1096312795"/>
       </p:ext>
     </p:extLst>
   </p:cSld>
@@ -4304,7 +4304,7 @@
           <p:cNvPr id="1" name="kicker-jpa-domain-model">
             <a:extLst xmlns:a="http://schemas.openxmlformats.org/drawingml/2006/main">
               <a:ext uri="{FF2B5EF4-FFF2-40B4-BE49-F238E27FC236}">
-                <a16:creationId xmlns:a16="http://schemas.microsoft.com/office/drawing/2014/main" id="{86CC4A00-21BA-4ACF-8995-38F9247D70E4}"/>
+                <a16:creationId xmlns:a16="http://schemas.microsoft.com/office/drawing/2014/main" id="{37DAB1A1-D8B2-49AB-B014-18DD9CAAD415}"/>
               </a:ext>
             </a:extLst>
           </p:cNvPr>
@@ -4349,7 +4349,7 @@
           <p:cNvPr id="2" name="entity-title">
             <a:extLst xmlns:a="http://schemas.openxmlformats.org/drawingml/2006/main">
               <a:ext uri="{FF2B5EF4-FFF2-40B4-BE49-F238E27FC236}">
-                <a16:creationId xmlns:a16="http://schemas.microsoft.com/office/drawing/2014/main" id="{E28D3959-47FB-4C80-A637-60C9B229712C}"/>
+                <a16:creationId xmlns:a16="http://schemas.microsoft.com/office/drawing/2014/main" id="{DF28E1F2-FC3F-49FB-8400-9A73957B1A19}"/>
               </a:ext>
             </a:extLst>
           </p:cNvPr>
@@ -4394,7 +4394,7 @@
           <p:cNvPr id="3" name="entity-subtitle">
             <a:extLst xmlns:a="http://schemas.openxmlformats.org/drawingml/2006/main">
               <a:ext uri="{FF2B5EF4-FFF2-40B4-BE49-F238E27FC236}">
-                <a16:creationId xmlns:a16="http://schemas.microsoft.com/office/drawing/2014/main" id="{26BCECAC-E5A3-47AD-8C65-5A2D43B778C2}"/>
+                <a16:creationId xmlns:a16="http://schemas.microsoft.com/office/drawing/2014/main" id="{AC0D949C-C5B3-4D6F-B59E-E3907EF1AE00}"/>
               </a:ext>
             </a:extLst>
           </p:cNvPr>
@@ -4439,7 +4439,7 @@
           <p:cNvPr id="4" name="entity-student">
             <a:extLst xmlns:a="http://schemas.openxmlformats.org/drawingml/2006/main">
               <a:ext uri="{FF2B5EF4-FFF2-40B4-BE49-F238E27FC236}">
-                <a16:creationId xmlns:a16="http://schemas.microsoft.com/office/drawing/2014/main" id="{23C2B009-F69D-411A-8C50-19A2727DB6E9}"/>
+                <a16:creationId xmlns:a16="http://schemas.microsoft.com/office/drawing/2014/main" id="{1B386B89-13C6-4ED4-8E9A-4B5E398ABCBC}"/>
               </a:ext>
             </a:extLst>
           </p:cNvPr>
@@ -4468,7 +4468,7 @@
           <p:cNvPr id="5" name="entity-student-heading">
             <a:extLst xmlns:a="http://schemas.openxmlformats.org/drawingml/2006/main">
               <a:ext uri="{FF2B5EF4-FFF2-40B4-BE49-F238E27FC236}">
-                <a16:creationId xmlns:a16="http://schemas.microsoft.com/office/drawing/2014/main" id="{5937E1A6-AA81-421E-8823-28B3D903DFC2}"/>
+                <a16:creationId xmlns:a16="http://schemas.microsoft.com/office/drawing/2014/main" id="{4FA36DB1-F82C-4520-AFA7-3A253137A8AD}"/>
               </a:ext>
             </a:extLst>
           </p:cNvPr>
@@ -4513,7 +4513,7 @@
           <p:cNvPr id="6" name="entity-student-body">
             <a:extLst xmlns:a="http://schemas.openxmlformats.org/drawingml/2006/main">
               <a:ext uri="{FF2B5EF4-FFF2-40B4-BE49-F238E27FC236}">
-                <a16:creationId xmlns:a16="http://schemas.microsoft.com/office/drawing/2014/main" id="{6ECC4F56-8D39-48CD-AC77-20A722F50017}"/>
+                <a16:creationId xmlns:a16="http://schemas.microsoft.com/office/drawing/2014/main" id="{18664A00-7EA1-4339-8925-76BBB3393AAF}"/>
               </a:ext>
             </a:extLst>
           </p:cNvPr>
@@ -4626,7 +4626,7 @@
           <p:cNvPr id="7" name="entity-resource">
             <a:extLst xmlns:a="http://schemas.openxmlformats.org/drawingml/2006/main">
               <a:ext uri="{FF2B5EF4-FFF2-40B4-BE49-F238E27FC236}">
-                <a16:creationId xmlns:a16="http://schemas.microsoft.com/office/drawing/2014/main" id="{1E959AB5-6F5C-4717-81D3-0116A44E2659}"/>
+                <a16:creationId xmlns:a16="http://schemas.microsoft.com/office/drawing/2014/main" id="{85DDBEAF-1BC6-4783-99E0-9F01A863F060}"/>
               </a:ext>
             </a:extLst>
           </p:cNvPr>
@@ -4655,7 +4655,7 @@
           <p:cNvPr id="8" name="entity-resource-heading">
             <a:extLst xmlns:a="http://schemas.openxmlformats.org/drawingml/2006/main">
               <a:ext uri="{FF2B5EF4-FFF2-40B4-BE49-F238E27FC236}">
-                <a16:creationId xmlns:a16="http://schemas.microsoft.com/office/drawing/2014/main" id="{BB6158C9-14B1-49CD-9B5E-1BFDAACF04A4}"/>
+                <a16:creationId xmlns:a16="http://schemas.microsoft.com/office/drawing/2014/main" id="{F851AD99-D71B-4406-B0CA-6C1F71B02918}"/>
               </a:ext>
             </a:extLst>
           </p:cNvPr>
@@ -4700,7 +4700,7 @@
           <p:cNvPr id="9" name="entity-resource-body">
             <a:extLst xmlns:a="http://schemas.openxmlformats.org/drawingml/2006/main">
               <a:ext uri="{FF2B5EF4-FFF2-40B4-BE49-F238E27FC236}">
-                <a16:creationId xmlns:a16="http://schemas.microsoft.com/office/drawing/2014/main" id="{CE1D6587-2D93-48E9-AE59-8419F82AB3B5}"/>
+                <a16:creationId xmlns:a16="http://schemas.microsoft.com/office/drawing/2014/main" id="{0AAF09C1-D930-4055-8661-768830933F6F}"/>
               </a:ext>
             </a:extLst>
           </p:cNvPr>
@@ -4803,7 +4803,7 @@
                   <a:srgbClr val="52616E"/>
                 </a:solidFill>
               </a:rPr>
-              <a:t>Quantity represents available stock</a:t>
+              <a:t>Quantity represents total capacity</a:t>
             </a:r>
           </a:p>
         </p:txBody>
@@ -4813,7 +4813,7 @@
           <p:cNvPr id="10" name="entity-flow">
             <a:extLst xmlns:a="http://schemas.openxmlformats.org/drawingml/2006/main">
               <a:ext uri="{FF2B5EF4-FFF2-40B4-BE49-F238E27FC236}">
-                <a16:creationId xmlns:a16="http://schemas.microsoft.com/office/drawing/2014/main" id="{5A08B136-9E86-43F9-B17C-578BDEFC8777}"/>
+                <a16:creationId xmlns:a16="http://schemas.microsoft.com/office/drawing/2014/main" id="{E0A7CD62-DC51-4CBD-BAFE-B0EADA2E2CA0}"/>
               </a:ext>
             </a:extLst>
           </p:cNvPr>
@@ -4842,7 +4842,7 @@
           <p:cNvPr id="11" name="entity-flow-heading">
             <a:extLst xmlns:a="http://schemas.openxmlformats.org/drawingml/2006/main">
               <a:ext uri="{FF2B5EF4-FFF2-40B4-BE49-F238E27FC236}">
-                <a16:creationId xmlns:a16="http://schemas.microsoft.com/office/drawing/2014/main" id="{277304A3-DEEC-4985-85D1-04DDE829D45D}"/>
+                <a16:creationId xmlns:a16="http://schemas.microsoft.com/office/drawing/2014/main" id="{4676435C-2376-47B6-8C4C-AA75A3A43759}"/>
               </a:ext>
             </a:extLst>
           </p:cNvPr>
@@ -4887,7 +4887,7 @@
           <p:cNvPr id="12" name="entity-flow-body">
             <a:extLst xmlns:a="http://schemas.openxmlformats.org/drawingml/2006/main">
               <a:ext uri="{FF2B5EF4-FFF2-40B4-BE49-F238E27FC236}">
-                <a16:creationId xmlns:a16="http://schemas.microsoft.com/office/drawing/2014/main" id="{2EBD108F-268D-4B23-9B97-490328F77A82}"/>
+                <a16:creationId xmlns:a16="http://schemas.microsoft.com/office/drawing/2014/main" id="{BEFA58FB-1498-440B-85BD-290ECE3FB797}"/>
               </a:ext>
             </a:extLst>
           </p:cNvPr>
@@ -5000,7 +5000,7 @@
           <p:cNvPr id="13" name="entity-note">
             <a:extLst xmlns:a="http://schemas.openxmlformats.org/drawingml/2006/main">
               <a:ext uri="{FF2B5EF4-FFF2-40B4-BE49-F238E27FC236}">
-                <a16:creationId xmlns:a16="http://schemas.microsoft.com/office/drawing/2014/main" id="{9370AF09-5C09-4623-AA4F-050827D907FB}"/>
+                <a16:creationId xmlns:a16="http://schemas.microsoft.com/office/drawing/2014/main" id="{BFD3A0B5-C97E-4377-ABE4-8D07E025ABF2}"/>
               </a:ext>
             </a:extLst>
           </p:cNvPr>
@@ -5043,7 +5043,7 @@
     </p:spTree>
     <p:extLst>
       <p:ext uri="{BB962C8B-B14F-4D97-AF65-F5344CB8AC3E}">
-        <p14:creationId xmlns:p14="http://schemas.microsoft.com/office/powerpoint/2010/main" val="759892579"/>
+        <p14:creationId xmlns:p14="http://schemas.microsoft.com/office/powerpoint/2010/main" val="1807343894"/>
       </p:ext>
     </p:extLst>
   </p:cSld>
@@ -5074,7 +5074,7 @@
           <p:cNvPr id="1" name="kicker-request-lifecycle">
             <a:extLst xmlns:a="http://schemas.openxmlformats.org/drawingml/2006/main">
               <a:ext uri="{FF2B5EF4-FFF2-40B4-BE49-F238E27FC236}">
-                <a16:creationId xmlns:a16="http://schemas.microsoft.com/office/drawing/2014/main" id="{7FD76EB9-C7B3-4FA0-809E-6DE462D5F320}"/>
+                <a16:creationId xmlns:a16="http://schemas.microsoft.com/office/drawing/2014/main" id="{61FD6D8F-5B4B-4968-8263-6EE78916F125}"/>
               </a:ext>
             </a:extLst>
           </p:cNvPr>
@@ -5119,7 +5119,7 @@
           <p:cNvPr id="2" name="request-title">
             <a:extLst xmlns:a="http://schemas.openxmlformats.org/drawingml/2006/main">
               <a:ext uri="{FF2B5EF4-FFF2-40B4-BE49-F238E27FC236}">
-                <a16:creationId xmlns:a16="http://schemas.microsoft.com/office/drawing/2014/main" id="{598E68A6-4C26-4D43-8F6A-91A16FBC2459}"/>
+                <a16:creationId xmlns:a16="http://schemas.microsoft.com/office/drawing/2014/main" id="{ACF76696-DC15-4697-AE10-912AA3675904}"/>
               </a:ext>
             </a:extLst>
           </p:cNvPr>
@@ -5164,7 +5164,7 @@
           <p:cNvPr id="3" name="request-controller">
             <a:extLst xmlns:a="http://schemas.openxmlformats.org/drawingml/2006/main">
               <a:ext uri="{FF2B5EF4-FFF2-40B4-BE49-F238E27FC236}">
-                <a16:creationId xmlns:a16="http://schemas.microsoft.com/office/drawing/2014/main" id="{2226D012-1F25-4BBC-AC31-3E621FF25136}"/>
+                <a16:creationId xmlns:a16="http://schemas.microsoft.com/office/drawing/2014/main" id="{932F2F43-9F97-4922-9C42-CBF687AB1BE4}"/>
               </a:ext>
             </a:extLst>
           </p:cNvPr>
@@ -5193,7 +5193,7 @@
           <p:cNvPr id="4" name="request-controller-heading">
             <a:extLst xmlns:a="http://schemas.openxmlformats.org/drawingml/2006/main">
               <a:ext uri="{FF2B5EF4-FFF2-40B4-BE49-F238E27FC236}">
-                <a16:creationId xmlns:a16="http://schemas.microsoft.com/office/drawing/2014/main" id="{D70EFD88-4D66-4E3F-803D-75C76FF2C843}"/>
+                <a16:creationId xmlns:a16="http://schemas.microsoft.com/office/drawing/2014/main" id="{0146A6D5-03DA-4278-9961-F0DA72B27F5A}"/>
               </a:ext>
             </a:extLst>
           </p:cNvPr>
@@ -5238,7 +5238,7 @@
           <p:cNvPr id="5" name="request-controller-body">
             <a:extLst xmlns:a="http://schemas.openxmlformats.org/drawingml/2006/main">
               <a:ext uri="{FF2B5EF4-FFF2-40B4-BE49-F238E27FC236}">
-                <a16:creationId xmlns:a16="http://schemas.microsoft.com/office/drawing/2014/main" id="{A76D0034-C1EB-411F-872D-1D0FB90657B4}"/>
+                <a16:creationId xmlns:a16="http://schemas.microsoft.com/office/drawing/2014/main" id="{EAA23E0E-A082-4B12-81B7-96BC0EBFD76D}"/>
               </a:ext>
             </a:extLst>
           </p:cNvPr>
@@ -5317,7 +5317,7 @@
           <p:cNvPr id="6" name="request-service">
             <a:extLst xmlns:a="http://schemas.openxmlformats.org/drawingml/2006/main">
               <a:ext uri="{FF2B5EF4-FFF2-40B4-BE49-F238E27FC236}">
-                <a16:creationId xmlns:a16="http://schemas.microsoft.com/office/drawing/2014/main" id="{D268A0D1-6778-42A8-9B2B-6A179231FCD3}"/>
+                <a16:creationId xmlns:a16="http://schemas.microsoft.com/office/drawing/2014/main" id="{5C4150F4-8958-490C-9D18-2893BCB6F267}"/>
               </a:ext>
             </a:extLst>
           </p:cNvPr>
@@ -5346,7 +5346,7 @@
           <p:cNvPr id="7" name="request-service-heading">
             <a:extLst xmlns:a="http://schemas.openxmlformats.org/drawingml/2006/main">
               <a:ext uri="{FF2B5EF4-FFF2-40B4-BE49-F238E27FC236}">
-                <a16:creationId xmlns:a16="http://schemas.microsoft.com/office/drawing/2014/main" id="{D5A56336-435F-4584-BC01-BB3559BC1970}"/>
+                <a16:creationId xmlns:a16="http://schemas.microsoft.com/office/drawing/2014/main" id="{7C5C25B5-F612-4926-907F-27F9F99625AE}"/>
               </a:ext>
             </a:extLst>
           </p:cNvPr>
@@ -5391,7 +5391,7 @@
           <p:cNvPr id="8" name="request-service-body">
             <a:extLst xmlns:a="http://schemas.openxmlformats.org/drawingml/2006/main">
               <a:ext uri="{FF2B5EF4-FFF2-40B4-BE49-F238E27FC236}">
-                <a16:creationId xmlns:a16="http://schemas.microsoft.com/office/drawing/2014/main" id="{78C99C8A-63C2-421E-8C5F-195BBA216E97}"/>
+                <a16:creationId xmlns:a16="http://schemas.microsoft.com/office/drawing/2014/main" id="{05658839-5363-401E-892B-B7242D5ECBCE}"/>
               </a:ext>
             </a:extLst>
           </p:cNvPr>
@@ -5487,7 +5487,7 @@
           <p:cNvPr id="9" name="request-repo">
             <a:extLst xmlns:a="http://schemas.openxmlformats.org/drawingml/2006/main">
               <a:ext uri="{FF2B5EF4-FFF2-40B4-BE49-F238E27FC236}">
-                <a16:creationId xmlns:a16="http://schemas.microsoft.com/office/drawing/2014/main" id="{F9697338-07D0-4523-AE4C-3F7047E6B907}"/>
+                <a16:creationId xmlns:a16="http://schemas.microsoft.com/office/drawing/2014/main" id="{58E4ED9C-4090-480B-8760-B916968557A1}"/>
               </a:ext>
             </a:extLst>
           </p:cNvPr>
@@ -5516,7 +5516,7 @@
           <p:cNvPr id="10" name="request-repo-heading">
             <a:extLst xmlns:a="http://schemas.openxmlformats.org/drawingml/2006/main">
               <a:ext uri="{FF2B5EF4-FFF2-40B4-BE49-F238E27FC236}">
-                <a16:creationId xmlns:a16="http://schemas.microsoft.com/office/drawing/2014/main" id="{2B5A7184-3E72-454A-9DAA-9A554F7BF56C}"/>
+                <a16:creationId xmlns:a16="http://schemas.microsoft.com/office/drawing/2014/main" id="{C29D731F-A5D8-44EB-A121-575F1A2B5262}"/>
               </a:ext>
             </a:extLst>
           </p:cNvPr>
@@ -5561,7 +5561,7 @@
           <p:cNvPr id="11" name="request-repo-body">
             <a:extLst xmlns:a="http://schemas.openxmlformats.org/drawingml/2006/main">
               <a:ext uri="{FF2B5EF4-FFF2-40B4-BE49-F238E27FC236}">
-                <a16:creationId xmlns:a16="http://schemas.microsoft.com/office/drawing/2014/main" id="{9F16DAA3-939E-4AB5-B684-10FD6659B590}"/>
+                <a16:creationId xmlns:a16="http://schemas.microsoft.com/office/drawing/2014/main" id="{6AD78D11-6999-4B90-BC4A-4B0374351CEB}"/>
               </a:ext>
             </a:extLst>
           </p:cNvPr>
@@ -5623,7 +5623,7 @@
           <p:cNvPr id="12" name="request-response">
             <a:extLst xmlns:a="http://schemas.openxmlformats.org/drawingml/2006/main">
               <a:ext uri="{FF2B5EF4-FFF2-40B4-BE49-F238E27FC236}">
-                <a16:creationId xmlns:a16="http://schemas.microsoft.com/office/drawing/2014/main" id="{231D4056-CFEF-4A91-8FB6-8D5D8F1D9A15}"/>
+                <a16:creationId xmlns:a16="http://schemas.microsoft.com/office/drawing/2014/main" id="{46267548-B25E-46B9-9E46-710A027F1558}"/>
               </a:ext>
             </a:extLst>
           </p:cNvPr>
@@ -5652,7 +5652,7 @@
           <p:cNvPr id="13" name="request-response-heading">
             <a:extLst xmlns:a="http://schemas.openxmlformats.org/drawingml/2006/main">
               <a:ext uri="{FF2B5EF4-FFF2-40B4-BE49-F238E27FC236}">
-                <a16:creationId xmlns:a16="http://schemas.microsoft.com/office/drawing/2014/main" id="{859E2C57-6081-45F5-BAE0-00E0D9590575}"/>
+                <a16:creationId xmlns:a16="http://schemas.microsoft.com/office/drawing/2014/main" id="{4457669B-2D37-458E-981A-34BD5157CCDA}"/>
               </a:ext>
             </a:extLst>
           </p:cNvPr>
@@ -5697,7 +5697,7 @@
           <p:cNvPr id="14" name="request-response-body">
             <a:extLst xmlns:a="http://schemas.openxmlformats.org/drawingml/2006/main">
               <a:ext uri="{FF2B5EF4-FFF2-40B4-BE49-F238E27FC236}">
-                <a16:creationId xmlns:a16="http://schemas.microsoft.com/office/drawing/2014/main" id="{72F3DB4A-E8D0-4A5A-B925-DDE3FE88834D}"/>
+                <a16:creationId xmlns:a16="http://schemas.microsoft.com/office/drawing/2014/main" id="{37F7E8E2-B0D6-4414-923B-64339003DC8E}"/>
               </a:ext>
             </a:extLst>
           </p:cNvPr>
@@ -5774,7 +5774,7 @@
     </p:spTree>
     <p:extLst>
       <p:ext uri="{BB962C8B-B14F-4D97-AF65-F5344CB8AC3E}">
-        <p14:creationId xmlns:p14="http://schemas.microsoft.com/office/powerpoint/2010/main" val="1808135883"/>
+        <p14:creationId xmlns:p14="http://schemas.microsoft.com/office/powerpoint/2010/main" val="1658645647"/>
       </p:ext>
     </p:extLst>
   </p:cSld>
@@ -5805,7 +5805,7 @@
           <p:cNvPr id="1" name="kicker-reservation-logic">
             <a:extLst xmlns:a="http://schemas.openxmlformats.org/drawingml/2006/main">
               <a:ext uri="{FF2B5EF4-FFF2-40B4-BE49-F238E27FC236}">
-                <a16:creationId xmlns:a16="http://schemas.microsoft.com/office/drawing/2014/main" id="{74EF47A9-C834-4A85-856B-838B80C668FE}"/>
+                <a16:creationId xmlns:a16="http://schemas.microsoft.com/office/drawing/2014/main" id="{C2D19364-F3A8-413B-9968-AB97D435C40D}"/>
               </a:ext>
             </a:extLst>
           </p:cNvPr>
@@ -5850,7 +5850,7 @@
           <p:cNvPr id="2" name="workflow-heading">
             <a:extLst xmlns:a="http://schemas.openxmlformats.org/drawingml/2006/main">
               <a:ext uri="{FF2B5EF4-FFF2-40B4-BE49-F238E27FC236}">
-                <a16:creationId xmlns:a16="http://schemas.microsoft.com/office/drawing/2014/main" id="{10EBD1CC-B7AE-4A62-BFE6-3E715F2F22EE}"/>
+                <a16:creationId xmlns:a16="http://schemas.microsoft.com/office/drawing/2014/main" id="{0646F51F-9EBB-43EE-9510-5BEAC42CEE95}"/>
               </a:ext>
             </a:extLst>
           </p:cNvPr>
@@ -5895,7 +5895,7 @@
           <p:cNvPr id="3" name="workflow-student">
             <a:extLst xmlns:a="http://schemas.openxmlformats.org/drawingml/2006/main">
               <a:ext uri="{FF2B5EF4-FFF2-40B4-BE49-F238E27FC236}">
-                <a16:creationId xmlns:a16="http://schemas.microsoft.com/office/drawing/2014/main" id="{893A21DD-073F-4988-B628-BDEF8876E5E2}"/>
+                <a16:creationId xmlns:a16="http://schemas.microsoft.com/office/drawing/2014/main" id="{36CA8D9A-9AF8-44DD-BA5E-4383B9414F97}"/>
               </a:ext>
             </a:extLst>
           </p:cNvPr>
@@ -5924,7 +5924,7 @@
           <p:cNvPr id="4" name="workflow-student-heading">
             <a:extLst xmlns:a="http://schemas.openxmlformats.org/drawingml/2006/main">
               <a:ext uri="{FF2B5EF4-FFF2-40B4-BE49-F238E27FC236}">
-                <a16:creationId xmlns:a16="http://schemas.microsoft.com/office/drawing/2014/main" id="{8F428B15-0578-4954-B585-934ED618A61F}"/>
+                <a16:creationId xmlns:a16="http://schemas.microsoft.com/office/drawing/2014/main" id="{17EBE972-8620-48A3-9948-9203A9A9A76C}"/>
               </a:ext>
             </a:extLst>
           </p:cNvPr>
@@ -5969,7 +5969,7 @@
           <p:cNvPr id="5" name="workflow-student-body">
             <a:extLst xmlns:a="http://schemas.openxmlformats.org/drawingml/2006/main">
               <a:ext uri="{FF2B5EF4-FFF2-40B4-BE49-F238E27FC236}">
-                <a16:creationId xmlns:a16="http://schemas.microsoft.com/office/drawing/2014/main" id="{EEAA8E5B-F9A5-49FA-98E2-27AB1363A6AB}"/>
+                <a16:creationId xmlns:a16="http://schemas.microsoft.com/office/drawing/2014/main" id="{548D9F94-33D7-4FC6-AB49-4FFDADBC32CC}"/>
               </a:ext>
             </a:extLst>
           </p:cNvPr>
@@ -6055,7 +6055,7 @@
                   <a:srgbClr val="52616E"/>
                 </a:solidFill>
               </a:rPr>
-              <a:t>Reservation cannot exceed 7 weekdays</a:t>
+              <a:t>Pending requests do not consume capacity yet</a:t>
             </a:r>
           </a:p>
         </p:txBody>
@@ -6065,7 +6065,7 @@
           <p:cNvPr id="6" name="workflow-admin">
             <a:extLst xmlns:a="http://schemas.openxmlformats.org/drawingml/2006/main">
               <a:ext uri="{FF2B5EF4-FFF2-40B4-BE49-F238E27FC236}">
-                <a16:creationId xmlns:a16="http://schemas.microsoft.com/office/drawing/2014/main" id="{AD16E3FF-8A00-446C-96B6-22463AD4DDEA}"/>
+                <a16:creationId xmlns:a16="http://schemas.microsoft.com/office/drawing/2014/main" id="{230E0A98-4930-43D6-BE3A-792F7B60FB15}"/>
               </a:ext>
             </a:extLst>
           </p:cNvPr>
@@ -6094,7 +6094,7 @@
           <p:cNvPr id="7" name="workflow-admin-heading">
             <a:extLst xmlns:a="http://schemas.openxmlformats.org/drawingml/2006/main">
               <a:ext uri="{FF2B5EF4-FFF2-40B4-BE49-F238E27FC236}">
-                <a16:creationId xmlns:a16="http://schemas.microsoft.com/office/drawing/2014/main" id="{D4E050C1-3F59-40EF-AD48-27C9BA1A534B}"/>
+                <a16:creationId xmlns:a16="http://schemas.microsoft.com/office/drawing/2014/main" id="{114B2E3D-F807-41CC-BE59-994F985D6EF8}"/>
               </a:ext>
             </a:extLst>
           </p:cNvPr>
@@ -6139,7 +6139,7 @@
           <p:cNvPr id="8" name="workflow-admin-body">
             <a:extLst xmlns:a="http://schemas.openxmlformats.org/drawingml/2006/main">
               <a:ext uri="{FF2B5EF4-FFF2-40B4-BE49-F238E27FC236}">
-                <a16:creationId xmlns:a16="http://schemas.microsoft.com/office/drawing/2014/main" id="{58DDCB94-598B-4E22-9626-EB6CC269CCB4}"/>
+                <a16:creationId xmlns:a16="http://schemas.microsoft.com/office/drawing/2014/main" id="{8056ADF0-3C6A-4B7F-B71A-675423A8AEBA}"/>
               </a:ext>
             </a:extLst>
           </p:cNvPr>
@@ -6151,7 +6151,7 @@
         <p:spPr>
           <a:xfrm xmlns:a="http://schemas.openxmlformats.org/drawingml/2006/main">
             <a:off x="6667500" y="2647950"/>
-            <a:ext cx="4953000" cy="971550"/>
+            <a:ext cx="4953000" cy="1200150"/>
           </a:xfrm>
           <a:prstGeom xmlns:a="http://schemas.openxmlformats.org/drawingml/2006/main" prst="rect">
             <a:avLst/>
@@ -6191,6 +6191,23 @@
                   <a:srgbClr val="52616E"/>
                 </a:solidFill>
               </a:rPr>
+              <a:t>Capacity is checked again for the selected dates</a:t>
+            </a:r>
+          </a:p>
+          <a:p xmlns:a="http://schemas.openxmlformats.org/drawingml/2006/main">
+            <a:pPr>
+              <a:defRPr sz="1575">
+                <a:solidFill>
+                  <a:srgbClr val="52616E"/>
+                </a:solidFill>
+              </a:defRPr>
+            </a:pPr>
+            <a:r>
+              <a:rPr sz="1575">
+                <a:solidFill>
+                  <a:srgbClr val="52616E"/>
+                </a:solidFill>
+              </a:rPr>
               <a:t>APPROVED if start date is in the future</a:t>
             </a:r>
           </a:p>
@@ -6225,7 +6242,7 @@
                   <a:srgbClr val="52616E"/>
                 </a:solidFill>
               </a:rPr>
-              <a:t>Stock is decremented only when active</a:t>
+              <a:t>Overflow requests are rejected and students are notified</a:t>
             </a:r>
           </a:p>
         </p:txBody>
@@ -6235,7 +6252,7 @@
           <p:cNvPr id="9" name="workflow-return">
             <a:extLst xmlns:a="http://schemas.openxmlformats.org/drawingml/2006/main">
               <a:ext uri="{FF2B5EF4-FFF2-40B4-BE49-F238E27FC236}">
-                <a16:creationId xmlns:a16="http://schemas.microsoft.com/office/drawing/2014/main" id="{419A8E2D-2DAE-4725-803B-2EAC46DD44BA}"/>
+                <a16:creationId xmlns:a16="http://schemas.microsoft.com/office/drawing/2014/main" id="{70C3D932-97B6-4C32-AEA1-60F57849A4C4}"/>
               </a:ext>
             </a:extLst>
           </p:cNvPr>
@@ -6264,7 +6281,7 @@
           <p:cNvPr id="10" name="workflow-return-heading">
             <a:extLst xmlns:a="http://schemas.openxmlformats.org/drawingml/2006/main">
               <a:ext uri="{FF2B5EF4-FFF2-40B4-BE49-F238E27FC236}">
-                <a16:creationId xmlns:a16="http://schemas.microsoft.com/office/drawing/2014/main" id="{467BC4C4-54E5-4596-BFB0-AD8A547744CD}"/>
+                <a16:creationId xmlns:a16="http://schemas.microsoft.com/office/drawing/2014/main" id="{0479A360-9083-4133-9063-F23674845E06}"/>
               </a:ext>
             </a:extLst>
           </p:cNvPr>
@@ -6309,7 +6326,7 @@
           <p:cNvPr id="11" name="workflow-return-body">
             <a:extLst xmlns:a="http://schemas.openxmlformats.org/drawingml/2006/main">
               <a:ext uri="{FF2B5EF4-FFF2-40B4-BE49-F238E27FC236}">
-                <a16:creationId xmlns:a16="http://schemas.microsoft.com/office/drawing/2014/main" id="{B5A4EBFA-5AB5-4259-AF60-78CF68CA43F3}"/>
+                <a16:creationId xmlns:a16="http://schemas.microsoft.com/office/drawing/2014/main" id="{3280345C-E3C4-41D0-82A3-AA8F6492DFDB}"/>
               </a:ext>
             </a:extLst>
           </p:cNvPr>
@@ -6386,7 +6403,7 @@
     </p:spTree>
     <p:extLst>
       <p:ext uri="{BB962C8B-B14F-4D97-AF65-F5344CB8AC3E}">
-        <p14:creationId xmlns:p14="http://schemas.microsoft.com/office/powerpoint/2010/main" val="1898257262"/>
+        <p14:creationId xmlns:p14="http://schemas.microsoft.com/office/powerpoint/2010/main" val="1448468669"/>
       </p:ext>
     </p:extLst>
   </p:cSld>
@@ -6417,7 +6434,7 @@
           <p:cNvPr id="1" name="kicker-automation-and-resilience">
             <a:extLst xmlns:a="http://schemas.openxmlformats.org/drawingml/2006/main">
               <a:ext uri="{FF2B5EF4-FFF2-40B4-BE49-F238E27FC236}">
-                <a16:creationId xmlns:a16="http://schemas.microsoft.com/office/drawing/2014/main" id="{2B3A5430-7D75-4ED7-B2AF-9CC244D15749}"/>
+                <a16:creationId xmlns:a16="http://schemas.microsoft.com/office/drawing/2014/main" id="{4C7848C8-F941-46BA-B68D-F9B023304660}"/>
               </a:ext>
             </a:extLst>
           </p:cNvPr>
@@ -6462,7 +6479,7 @@
           <p:cNvPr id="2" name="notification-heading">
             <a:extLst xmlns:a="http://schemas.openxmlformats.org/drawingml/2006/main">
               <a:ext uri="{FF2B5EF4-FFF2-40B4-BE49-F238E27FC236}">
-                <a16:creationId xmlns:a16="http://schemas.microsoft.com/office/drawing/2014/main" id="{8D4D60A4-4A25-4ADC-B934-96A19ECA8796}"/>
+                <a16:creationId xmlns:a16="http://schemas.microsoft.com/office/drawing/2014/main" id="{B149CD48-E8E1-472B-9F4D-B3B56D644C1D}"/>
               </a:ext>
             </a:extLst>
           </p:cNvPr>
@@ -6507,7 +6524,7 @@
           <p:cNvPr id="3" name="scheduler-card">
             <a:extLst xmlns:a="http://schemas.openxmlformats.org/drawingml/2006/main">
               <a:ext uri="{FF2B5EF4-FFF2-40B4-BE49-F238E27FC236}">
-                <a16:creationId xmlns:a16="http://schemas.microsoft.com/office/drawing/2014/main" id="{9CA8F2DE-06E5-4591-8251-8C342CFECC53}"/>
+                <a16:creationId xmlns:a16="http://schemas.microsoft.com/office/drawing/2014/main" id="{523A5FDF-D59F-4BDE-8228-472979F20CD2}"/>
               </a:ext>
             </a:extLst>
           </p:cNvPr>
@@ -6536,7 +6553,7 @@
           <p:cNvPr id="4" name="scheduler-card-heading">
             <a:extLst xmlns:a="http://schemas.openxmlformats.org/drawingml/2006/main">
               <a:ext uri="{FF2B5EF4-FFF2-40B4-BE49-F238E27FC236}">
-                <a16:creationId xmlns:a16="http://schemas.microsoft.com/office/drawing/2014/main" id="{43902E01-7A65-47FD-BDFC-A61EB0CA7925}"/>
+                <a16:creationId xmlns:a16="http://schemas.microsoft.com/office/drawing/2014/main" id="{FD8579EB-C8E9-4477-A698-1367C866B2F1}"/>
               </a:ext>
             </a:extLst>
           </p:cNvPr>
@@ -6581,7 +6598,7 @@
           <p:cNvPr id="5" name="scheduler-card-body">
             <a:extLst xmlns:a="http://schemas.openxmlformats.org/drawingml/2006/main">
               <a:ext uri="{FF2B5EF4-FFF2-40B4-BE49-F238E27FC236}">
-                <a16:creationId xmlns:a16="http://schemas.microsoft.com/office/drawing/2014/main" id="{EDD18F1D-CCCE-4051-B4DF-8EC707ED8931}"/>
+                <a16:creationId xmlns:a16="http://schemas.microsoft.com/office/drawing/2014/main" id="{46982AC0-BB9B-4504-B073-DD58997A3118}"/>
               </a:ext>
             </a:extLst>
           </p:cNvPr>
@@ -6593,7 +6610,7 @@
         <p:spPr>
           <a:xfrm xmlns:a="http://schemas.openxmlformats.org/drawingml/2006/main">
             <a:off x="1028700" y="2647950"/>
-            <a:ext cx="7753350" cy="971550"/>
+            <a:ext cx="7753350" cy="1200150"/>
           </a:xfrm>
           <a:prstGeom xmlns:a="http://schemas.openxmlformats.org/drawingml/2006/main" prst="rect">
             <a:avLst/>
@@ -6667,6 +6684,23 @@
                   <a:srgbClr val="52616E"/>
                 </a:solidFill>
               </a:rPr>
+              <a:t>ReservationService creates request, approval, and rejection notifications immediately.</a:t>
+            </a:r>
+          </a:p>
+          <a:p xmlns:a="http://schemas.openxmlformats.org/drawingml/2006/main">
+            <a:pPr>
+              <a:defRPr sz="1575">
+                <a:solidFill>
+                  <a:srgbClr val="52616E"/>
+                </a:solidFill>
+              </a:defRPr>
+            </a:pPr>
+            <a:r>
+              <a:rPr sz="1575">
+                <a:solidFill>
+                  <a:srgbClr val="52616E"/>
+                </a:solidFill>
+              </a:rPr>
               <a:t>Admins can send manual overdue alerts to students.</a:t>
             </a:r>
           </a:p>
@@ -6677,7 +6711,7 @@
           <p:cNvPr id="6" name="exception-card">
             <a:extLst xmlns:a="http://schemas.openxmlformats.org/drawingml/2006/main">
               <a:ext uri="{FF2B5EF4-FFF2-40B4-BE49-F238E27FC236}">
-                <a16:creationId xmlns:a16="http://schemas.microsoft.com/office/drawing/2014/main" id="{1605B335-5E74-43B8-9A74-52DB4EB1FA4E}"/>
+                <a16:creationId xmlns:a16="http://schemas.microsoft.com/office/drawing/2014/main" id="{C3BC9254-63A9-48BB-BC92-753E0D51718C}"/>
               </a:ext>
             </a:extLst>
           </p:cNvPr>
@@ -6706,7 +6740,7 @@
           <p:cNvPr id="7" name="exception-card-heading">
             <a:extLst xmlns:a="http://schemas.openxmlformats.org/drawingml/2006/main">
               <a:ext uri="{FF2B5EF4-FFF2-40B4-BE49-F238E27FC236}">
-                <a16:creationId xmlns:a16="http://schemas.microsoft.com/office/drawing/2014/main" id="{F88950DC-D567-49FC-9B5E-71D9BD916DAF}"/>
+                <a16:creationId xmlns:a16="http://schemas.microsoft.com/office/drawing/2014/main" id="{AD8A10B2-388C-440C-88F4-47F160744EFB}"/>
               </a:ext>
             </a:extLst>
           </p:cNvPr>
@@ -6751,7 +6785,7 @@
           <p:cNvPr id="8" name="exception-card-body">
             <a:extLst xmlns:a="http://schemas.openxmlformats.org/drawingml/2006/main">
               <a:ext uri="{FF2B5EF4-FFF2-40B4-BE49-F238E27FC236}">
-                <a16:creationId xmlns:a16="http://schemas.microsoft.com/office/drawing/2014/main" id="{97551AB3-76C5-4925-8B18-890CDBB35EBB}"/>
+                <a16:creationId xmlns:a16="http://schemas.microsoft.com/office/drawing/2014/main" id="{935AA4E2-DD9F-46E3-9769-0F0372E39A3D}"/>
               </a:ext>
             </a:extLst>
           </p:cNvPr>
@@ -6828,7 +6862,7 @@
     </p:spTree>
     <p:extLst>
       <p:ext uri="{BB962C8B-B14F-4D97-AF65-F5344CB8AC3E}">
-        <p14:creationId xmlns:p14="http://schemas.microsoft.com/office/powerpoint/2010/main" val="813189204"/>
+        <p14:creationId xmlns:p14="http://schemas.microsoft.com/office/powerpoint/2010/main" val="849502987"/>
       </p:ext>
     </p:extLst>
   </p:cSld>
@@ -6859,7 +6893,7 @@
           <p:cNvPr id="1" name="kicker-important-code-files">
             <a:extLst xmlns:a="http://schemas.openxmlformats.org/drawingml/2006/main">
               <a:ext uri="{FF2B5EF4-FFF2-40B4-BE49-F238E27FC236}">
-                <a16:creationId xmlns:a16="http://schemas.microsoft.com/office/drawing/2014/main" id="{C253DE22-1C4A-4131-B832-32FB5885CF57}"/>
+                <a16:creationId xmlns:a16="http://schemas.microsoft.com/office/drawing/2014/main" id="{9B17F385-12BF-49A7-8F44-F181B67D0473}"/>
               </a:ext>
             </a:extLst>
           </p:cNvPr>
@@ -6904,7 +6938,7 @@
           <p:cNvPr id="2" name="files-heading">
             <a:extLst xmlns:a="http://schemas.openxmlformats.org/drawingml/2006/main">
               <a:ext uri="{FF2B5EF4-FFF2-40B4-BE49-F238E27FC236}">
-                <a16:creationId xmlns:a16="http://schemas.microsoft.com/office/drawing/2014/main" id="{586BD9FF-62D5-4243-8484-072FC05A6D14}"/>
+                <a16:creationId xmlns:a16="http://schemas.microsoft.com/office/drawing/2014/main" id="{F991F30B-D367-4189-87A3-2F0C7B9CF2ED}"/>
               </a:ext>
             </a:extLst>
           </p:cNvPr>
@@ -6949,7 +6983,7 @@
           <p:cNvPr id="3" name="files-left">
             <a:extLst xmlns:a="http://schemas.openxmlformats.org/drawingml/2006/main">
               <a:ext uri="{FF2B5EF4-FFF2-40B4-BE49-F238E27FC236}">
-                <a16:creationId xmlns:a16="http://schemas.microsoft.com/office/drawing/2014/main" id="{F5CD8848-027F-4E8D-B108-049D616FE6C1}"/>
+                <a16:creationId xmlns:a16="http://schemas.microsoft.com/office/drawing/2014/main" id="{BB402ECA-034C-449F-AF13-10E1E17BB1AD}"/>
               </a:ext>
             </a:extLst>
           </p:cNvPr>
@@ -7001,7 +7035,7 @@
                   <a:srgbClr val="52616E"/>
                 </a:solidFill>
               </a:rPr>
-              <a:t>• ReservationService.java: main business logic for reservation creation, approval, status refresh, and stock rules.</a:t>
+              <a:t>• ReservationService.java: main business logic for reservation creation, approval, status refresh, and capacity rules.</a:t>
             </a:r>
           </a:p>
           <a:p xmlns:a="http://schemas.openxmlformats.org/drawingml/2006/main">
@@ -7018,7 +7052,7 @@
                   <a:srgbClr val="52616E"/>
                 </a:solidFill>
               </a:rPr>
-              <a:t>• NotificationService.java: automatic reminders and manual overdue alerts.</a:t>
+              <a:t>• NotificationService.java: request, approval, rejection, reminder, and overdue alerts.</a:t>
             </a:r>
           </a:p>
           <a:p xmlns:a="http://schemas.openxmlformats.org/drawingml/2006/main">
@@ -7035,7 +7069,7 @@
                   <a:srgbClr val="52616E"/>
                 </a:solidFill>
               </a:rPr>
-              <a:t>• StudentService.java: student CRUD, login, and profile mapping.</a:t>
+              <a:t>• AuthService.java and SecurityConfig.java: JWT login and role-based access control.</a:t>
             </a:r>
           </a:p>
           <a:p xmlns:a="http://schemas.openxmlformats.org/drawingml/2006/main">
@@ -7062,7 +7096,7 @@
           <p:cNvPr id="4" name="files-right">
             <a:extLst xmlns:a="http://schemas.openxmlformats.org/drawingml/2006/main">
               <a:ext uri="{FF2B5EF4-FFF2-40B4-BE49-F238E27FC236}">
-                <a16:creationId xmlns:a16="http://schemas.microsoft.com/office/drawing/2014/main" id="{83B85638-3F4A-415D-BB96-37483A1AC881}"/>
+                <a16:creationId xmlns:a16="http://schemas.microsoft.com/office/drawing/2014/main" id="{B2E8C299-9304-4109-BC27-F013A4A4327D}"/>
               </a:ext>
             </a:extLst>
           </p:cNvPr>
@@ -7165,7 +7199,7 @@
                   <a:srgbClr val="52616E"/>
                 </a:solidFill>
               </a:rPr>
-              <a:t>• application.properties: ports, H2, JPA, active profile, and custom app properties.</a:t>
+              <a:t>• application.properties: ports, MySQL, JPA, and custom app properties.</a:t>
             </a:r>
           </a:p>
         </p:txBody>
@@ -7173,7 +7207,7 @@
     </p:spTree>
     <p:extLst>
       <p:ext uri="{BB962C8B-B14F-4D97-AF65-F5344CB8AC3E}">
-        <p14:creationId xmlns:p14="http://schemas.microsoft.com/office/powerpoint/2010/main" val="330592421"/>
+        <p14:creationId xmlns:p14="http://schemas.microsoft.com/office/powerpoint/2010/main" val="1852280852"/>
       </p:ext>
     </p:extLst>
   </p:cSld>

</xml_diff>